<commit_message>
docs(deck): real repository URL on close slide; regenerate pptx, pdf, preview
Co-Authored-By: Claude Sonnet 5.5 <noreply@anthropic.com>
</commit_message>
<xml_diff>
--- a/docs/deck/ScamShield-Immune.pptx
+++ b/docs/deck/ScamShield-Immune.pptx
@@ -1991,7 +1991,7 @@
           <a:lstStyle/>
           <a:p>
             <a:r>
-              <a:t>Close: one detection, every bank protected, every action auditable. Everything is simulated and says so. make demo builds the console and serves it at http://localhost:8080 (README quickstart). A recorded hero run with captions is in docs/demo/ (no narration; the script is docs/demo-script.md). Repository URL is a placeholder to fill in before sharing.</a:t>
+              <a:t>Close: one detection, every bank protected, every action auditable. Everything is simulated and says so. make demo builds the console and serves it at http://localhost:8080 (README quickstart). A recorded hero run with captions is in docs/demo/ (no narration; the script is docs/demo-script.md). The repository is https://github.com/aman-18-choudhary/ai_powered_immune; the work is on branch build/implementation, main holds only the design docs.</a:t>
             </a:r>
           </a:p>
           <a:p/>
@@ -9387,7 +9387,7 @@
                 </a:solidFill>
                 <a:latin typeface="Arial"/>
               </a:rPr>
-              <a:t>Repository: &lt;repo URL placeholder&gt;</a:t>
+              <a:t>github.com/aman-18-choudhary/ai_powered_immune (branch build/implementation)</a:t>
             </a:r>
           </a:p>
         </p:txBody>

</xml_diff>